<commit_message>
Separate legal price incidence from price fraud in subsidy case
Clarify on the air-conditioner slide that a price rise driven by supply
and demand is lawful incidence while a fictitious original price is
fraud, and note Zhejiang's own retail slowdown in the speaker notes.

Co-Authored-By: Claude Opus 5.5 <noreply@anthropic.com>
Claude-Session: https://claude.ai/code/session_01FLxSBozVAokE5ye9s5Y9KU
</commit_message>
<xml_diff>
--- a/talks/2026-10-consumption-regulation/信心与信任_讲座课件_第二稿.pptx
+++ b/talks/2026-10-consumption-regulation/信心与信任_讲座课件_第二稿.pptx
@@ -153,7 +153,7 @@
   <p:extLst>
     <p:ext uri="{521415D9-36F7-43E2-AB2F-B90AF26B5E84}">
       <p14:sectionLst xmlns:p14="http://schemas.microsoft.com/office/powerpoint/2010/main">
-        <p14:section name="开篇" id="{2f405b7a-8bc1-5ce4-d935-d981a89ad44f}">
+        <p14:section name="开篇" id="{b4471d92-8c26-760e-6657-1955267ea63c}">
           <p14:sldIdLst>
             <p14:sldId id="256"/>
             <p14:sldId id="257"/>
@@ -161,7 +161,7 @@
             <p14:sldId id="259"/>
           </p14:sldIdLst>
         </p14:section>
-        <p14:section name="一、观势" id="{43bd4d00-ad1a-883c-1091-e99e7eef2940}">
+        <p14:section name="一、观势" id="{7abc8752-e4cf-f2db-a738-b0ceecd9deb9}">
           <p14:sldIdLst>
             <p14:sldId id="260"/>
             <p14:sldId id="261"/>
@@ -172,7 +172,7 @@
             <p14:sldId id="266"/>
           </p14:sldIdLst>
         </p14:section>
-        <p14:section name="二、析因" id="{208e5c14-7e7c-0f7e-23f4-de39b9990877}">
+        <p14:section name="二、析因" id="{9425cadf-cec2-e3ca-96a5-befbfd3b6e2b}">
           <p14:sldIdLst>
             <p14:sldId id="267"/>
             <p14:sldId id="268"/>
@@ -188,14 +188,14 @@
             <p14:sldId id="278"/>
           </p14:sldIdLst>
         </p14:section>
-        <p14:section name="三、镜鉴" id="{6fd5099b-5efe-5d62-9f30-c371d204d584}">
+        <p14:section name="三、镜鉴" id="{0af8b724-1828-4784-6847-2cc36d30a681}">
           <p14:sldIdLst>
             <p14:sldId id="279"/>
             <p14:sldId id="280"/>
             <p14:sldId id="281"/>
           </p14:sldIdLst>
         </p14:section>
-        <p14:section name="四、谋策" id="{d82e22b5-5208-4c68-7f22-d8b773f71f59}">
+        <p14:section name="四、谋策" id="{36ce6c3e-df20-b4db-5552-f08e46469b04}">
           <p14:sldIdLst>
             <p14:sldId id="282"/>
             <p14:sldId id="283"/>
@@ -204,7 +204,7 @@
             <p14:sldId id="286"/>
           </p14:sldIdLst>
         </p14:section>
-        <p14:section name="五、作为" id="{2161df2a-da5e-06a9-35fa-59231032f3d5}">
+        <p14:section name="五、作为" id="{bdd920f8-023b-d81e-e750-e8585b555f94}">
           <p14:sldIdLst>
             <p14:sldId id="287"/>
             <p14:sldId id="288"/>
@@ -219,7 +219,7 @@
             <p14:sldId id="297"/>
           </p14:sldIdLst>
         </p14:section>
-        <p14:section name="结语" id="{513908e1-34cd-ea70-a13d-db25f6a8a88a}">
+        <p14:section name="结语" id="{48af3af4-d1e4-088f-48ea-b796cfe2c5e1}">
           <p14:sldIdLst>
             <p14:sldId id="298"/>
             <p14:sldId id="299"/>
@@ -9940,7 +9940,7 @@
             <a:r>
               <a:rPr lang="en-US" dirty="0"/>
               <a:t>【约2.5分钟，现场互动】先请大家心算：原价3000元的空调，补贴600元，商家补贴前先把标价提了300元——消费者实得多少？
-揭晓：实付2700元，比原价只省了300元。600元补贴里，消费者拿到一半，另一半被“先提价”截留了——补贴归宿只有50%。如果买家里有一半本来就会买，那么真正“撬动”的新增购买也只有一半。这就是两把尺子同时打折。
+揭晓：实付2700元，比原价只省了300元。600元补贴里，消费者拿到一半——补贴归宿只有50%。要分清两种情况：如果提价是因为补贴拉动需求、供给一时跟不上，这是合法的市场归宿，监管不该管；如果是虚构原价、先提价后打折，就是价格欺诈，必须查。（今年家电补贴比例已从20%降到15%、单件上限从2000元降到1500元，示意数字按去年口径。）如果买家里有一半本来就会买，那么真正“撬动”的新增购买也只有一半。这就是两把尺子同时打折。
 这不是假设：2025年下半年，国家发展改革委会同商务部等部门集中整治了5类问题，其中就有骗补套补和经销商、平台“先涨后补”；2026年起，参与经营主体要履行价格备案、承诺和公示，违规的取消资格。
 法律依据：《明码标价和禁止价格欺诈规定》——不得虚构被比较价格，不得临时提高标价作为折扣基准（讲前核对具体条号）。部门分工：商务部门管资格与资金，可取消资格、追回补贴；市场监管管价格、能效标识、质量和售后，可查处并纳入失信。
 （如有本人研究中的价格传导率数字，在此补充一句。）</a:t>
@@ -10391,7 +10391,7 @@
           <a:p>
             <a:r>
               <a:rPr lang="en-US" dirty="0"/>
-              <a:t>【约3分钟】上半年浙江GDP增长5.7%、社零增长3.0%，都高于全国。要讲公道：差异首先来自收入水平和市场活力，消费环境是加分项——相关不等于因果。放心消费能否带来额外增量，要用投诉率、复购率、商圈客流做前后对比来证明，这是我们可以一起做的评估。
+              <a:t>【约3分钟】上半年浙江GDP增长5.7%、社零增长3.0%，都高于全国。要讲公道：差异首先来自收入水平和市场活力，消费环境是加分项——相关不等于因果；而且浙江社零增速也从一季度的4.0%回落到了上半年的3.0%，我们同样面临压力。放心消费能否带来额外增量，要用投诉率、复购率、商圈客流做前后对比来证明，这是我们可以一起做的评估。
 几项有辨识度的工作：2017年起“放心消费在浙江”；“放心贷”把商户的“守信”变成“低息”；7个项目入选总局优化消费环境试点，全国第一；温州依托“浙食链”的全链条数字化监管入选国务院食安办2026年7月发布的典型案例；“放心贷”还为商户减免手续费约1.98亿元、节约利息约10.3亿元；“浙江外卖在线”2021年上线，平台证照核验累计拦截异常入驻4.2万家次。
 【三个追问，留给大家】无理由退货承诺单元超过1万家，消费者知道吗、用过吗？“放心贷”带动的是新增消费，还是替代了商户原有融资？7个试点，哪一个能复制到您所在的地市？
 【互动】请课前约好的衢州局同志用1—2分钟讲一个本地案例。</a:t>
@@ -35543,12 +35543,12 @@
         </p:nvSpPr>
         <p:spPr>
           <a:xfrm>
-            <a:off x="731520" y="1417320"/>
-            <a:ext cx="6126480" cy="548640"/>
+            <a:off x="731520" y="1371600"/>
+            <a:ext cx="6126480" cy="713232"/>
           </a:xfrm>
           <a:prstGeom prst="roundRect">
             <a:avLst>
-              <a:gd name="adj" fmla="val 13333"/>
+              <a:gd name="adj" fmla="val 10256"/>
             </a:avLst>
           </a:prstGeom>
           <a:solidFill>
@@ -35570,8 +35570,8 @@
         </p:nvSpPr>
         <p:spPr>
           <a:xfrm>
-            <a:off x="914400" y="1417320"/>
-            <a:ext cx="5852160" cy="548640"/>
+            <a:off x="868680" y="1371600"/>
+            <a:ext cx="5897880" cy="713232"/>
           </a:xfrm>
           <a:prstGeom prst="rect">
             <a:avLst/>
@@ -35587,7 +35587,7 @@
               <a:buNone/>
             </a:pPr>
             <a:r>
-              <a:rPr lang="zh-CN" altLang="en-US" sz="1600" dirty="0">
+              <a:rPr lang="zh-CN" altLang="en-US" sz="1300" dirty="0">
                 <a:solidFill>
                   <a:schemeClr val="tx1"/>
                 </a:solidFill>
@@ -35598,7 +35598,7 @@
               <a:t>消费者实得 </a:t>
             </a:r>
             <a:r>
-              <a:rPr lang="zh-CN" altLang="en-US" sz="1600" b="1" dirty="0">
+              <a:rPr lang="zh-CN" altLang="en-US" sz="1300" b="1" dirty="0">
                 <a:solidFill>
                   <a:schemeClr val="accent2"/>
                 </a:solidFill>
@@ -35609,7 +35609,7 @@
               <a:t>300元</a:t>
             </a:r>
             <a:r>
-              <a:rPr lang="zh-CN" altLang="en-US" sz="1600" dirty="0">
+              <a:rPr lang="zh-CN" altLang="en-US" sz="1300" dirty="0">
                 <a:solidFill>
                   <a:schemeClr val="tx1"/>
                 </a:solidFill>
@@ -35617,20 +35617,21 @@
                 <a:ea typeface="Microsoft YaHei" pitchFamily="34" charset="-122"/>
                 <a:cs typeface="Microsoft YaHei" pitchFamily="34" charset="-120"/>
               </a:rPr>
-              <a:t>（归宿50%），经营者截留 </a:t>
-            </a:r>
-            <a:r>
-              <a:rPr lang="zh-CN" altLang="en-US" sz="1600" b="1" dirty="0">
-                <a:solidFill>
-                  <a:schemeClr val="accent2"/>
-                </a:solidFill>
-                <a:latin typeface="Microsoft YaHei" pitchFamily="34" charset="0"/>
-                <a:ea typeface="Microsoft YaHei" pitchFamily="34" charset="-122"/>
-                <a:cs typeface="Microsoft YaHei" pitchFamily="34" charset="-120"/>
-              </a:rPr>
-              <a:t>300元</a:t>
-            </a:r>
-            <a:endParaRPr lang="zh-CN" sz="1600" dirty="0"/>
+              <a:t>（归宿50%），另300元归经营者</a:t>
+            </a:r>
+            <a:br/>
+            <a:r>
+              <a:rPr lang="zh-CN" altLang="en-US" sz="1300" dirty="0">
+                <a:solidFill>
+                  <a:schemeClr val="tx1"/>
+                </a:solidFill>
+                <a:latin typeface="Microsoft YaHei" pitchFamily="34" charset="0"/>
+                <a:ea typeface="Microsoft YaHei" pitchFamily="34" charset="-122"/>
+                <a:cs typeface="Microsoft YaHei" pitchFamily="34" charset="-120"/>
+              </a:rPr>
+              <a:t>提价源于供需变化＝合法的市场归宿；虚构原价、先提价后打折＝价格欺诈</a:t>
+            </a:r>
+            <a:endParaRPr lang="zh-CN" sz="1300" dirty="0"/>
           </a:p>
         </p:txBody>
       </p:sp>

</xml_diff>